<commit_message>
Replace unstyled ScreenSpot-Pro screenshot with official dataset page
</commit_message>
<xml_diff>
--- a/slides/datasets-in-10-minutes-screenspot-pro.pptx
+++ b/slides/datasets-in-10-minutes-screenspot-pro.pptx
@@ -12776,7 +12776,7 @@
                 <a:ea typeface="Noto Sans CJK JP"/>
                 <a:cs typeface="Noto Sans"/>
               </a:rPr>
-              <a:t>公式リポジトリ</a:t>
+              <a:t>公式データ配布ページ</a:t>
             </a:r>
           </a:p>
         </p:txBody>
@@ -12824,14 +12824,14 @@
                 <a:ea typeface="Noto Sans CJK JP"/>
                 <a:cs typeface="Noto Sans"/>
               </a:rPr>
-              <a:t>ScreenSpot-Proの公式リポジトリ</a:t>
+              <a:t>ScreenSpot-Proの公式配布ページ</a:t>
             </a:r>
           </a:p>
         </p:txBody>
       </p:sp>
       <p:pic>
         <p:nvPicPr>
-          <p:cNvPr id="4" name="Picture 3" descr="official-repo.png"/>
+          <p:cNvPr id="4" name="Picture 3" descr="official-dataset.png"/>
           <p:cNvPicPr>
             <a:picLocks noChangeAspect="1"/>
           </p:cNvPicPr>
@@ -12845,8 +12845,8 @@
         </p:blipFill>
         <p:spPr>
           <a:xfrm>
-            <a:off x="2257552" y="1481328"/>
-            <a:ext cx="4628896" cy="3063240"/>
+            <a:off x="2274570" y="1481328"/>
+            <a:ext cx="4594859" cy="3063240"/>
           </a:xfrm>
           <a:prstGeom prst="rect">
             <a:avLst/>
@@ -12913,22 +12913,8 @@
                 <a:ea typeface="Noto Sans CJK JP"/>
                 <a:cs typeface="Noto Sans"/>
               </a:rPr>
-              <a:t>Li et al. (2025). ScreenSpot-Pro: GUI Grounding for Professional High-Resolution Computer Use. 公式GitHub。2026-10-16参照。</a:t>
-            </a:r>
-          </a:p>
-          <a:p>
-            <a:pPr>
-              <a:lnSpc>
-                <a:spcPct val="112000"/>
-              </a:lnSpc>
-              <a:buNone/>
-              <a:defRPr sz="810" b="0">
-                <a:solidFill>
-                  <a:srgbClr val="303437"/>
-                </a:solidFill>
-                <a:latin typeface="Noto Sans"/>
-              </a:defRPr>
-            </a:pPr>
+              <a:t>Li et al. (2025). ScreenSpot-Pro: Data Details. 2026-10-16参照。</a:t>
+            </a:r>
             <a:r>
               <a:rPr sz="810" b="0" lang="ja-JP" altLang="en-US">
                 <a:solidFill>
@@ -12937,9 +12923,20 @@
                 <a:latin typeface="Noto Sans"/>
                 <a:ea typeface="Noto Sans CJK JP"/>
                 <a:cs typeface="Noto Sans"/>
+              </a:rPr>
+              <a:t>  </a:t>
+            </a:r>
+            <a:r>
+              <a:rPr sz="810" b="0" lang="ja-JP" altLang="en-US">
+                <a:solidFill>
+                  <a:srgbClr val="626669"/>
+                </a:solidFill>
+                <a:latin typeface="Noto Sans"/>
+                <a:ea typeface="Noto Sans CJK JP"/>
+                <a:cs typeface="Noto Sans"/>
                 <a:hlinkClick r:id="rId3"/>
               </a:rPr>
-              <a:t>https://github.com/likaixin2000/ScreenSpot-Pro-GUI-Grounding</a:t>
+              <a:t>https://huggingface.co/datasets/likaixin/ScreenSpot-Pro</a:t>
             </a:r>
           </a:p>
         </p:txBody>

</xml_diff>

<commit_message>
Proofread screenspot-pro slides page by page with Gemini
</commit_message>
<xml_diff>
--- a/slides/datasets-in-10-minutes-screenspot-pro.pptx
+++ b/slides/datasets-in-10-minutes-screenspot-pro.pptx
@@ -7833,7 +7833,7 @@
                 <a:ea typeface="Noto Sans CJK JP"/>
                 <a:cs typeface="Noto Sans"/>
               </a:rPr>
-              <a:t>実例2は、3D画面上部の設定を探す</a:t>
+              <a:t>実例2では、3D画面上部の設定を探す</a:t>
             </a:r>
           </a:p>
         </p:txBody>
@@ -11193,7 +11193,7 @@
                           <a:ea typeface="Noto Sans CJK JP"/>
                           <a:cs typeface="Noto Sans"/>
                         </a:rPr>
-                        <a:t>OpenAIの公表表のモデル</a:t>
+                        <a:t>OpenAI公表のモデル</a:t>
                       </a:r>
                     </a:p>
                   </a:txBody>
@@ -11517,7 +11517,7 @@
                           <a:ea typeface="Noto Sans CJK JP"/>
                           <a:cs typeface="Noto Sans"/>
                         </a:rPr>
-                        <a:t>Fable 5欄（Mythos）</a:t>
+                        <a:t>Mythos（Fable 5欄）</a:t>
                       </a:r>
                     </a:p>
                   </a:txBody>
@@ -11865,7 +11865,7 @@
                 <a:spcPts val="2760"/>
               </a:lnSpc>
               <a:spcAft>
-                <a:spcPts val="800"/>
+                <a:spcPts val="0"/>
               </a:spcAft>
               <a:buSzPct val="57826"/>
               <a:buFont typeface="Noto Sans CJK JP"/>
@@ -11886,7 +11886,7 @@
                 <a:ea typeface="Noto Sans CJK JP"/>
                 <a:cs typeface="Noto Sans"/>
               </a:rPr>
-              <a:t>Liら（2025）は、計画役にGPT-4o、位置推定役にOS-Atlas-7Bを使った。</a:t>
+              <a:t>メニューやパネルの構造を手掛かりに候補領域を選び、画像を切り出して段階的に絞り込む。</a:t>
             </a:r>
           </a:p>
           <a:p>
@@ -11895,7 +11895,7 @@
                 <a:spcPts val="2760"/>
               </a:lnSpc>
               <a:spcAft>
-                <a:spcPts val="0"/>
+                <a:spcPts val="800"/>
               </a:spcAft>
               <a:buSzPct val="57826"/>
               <a:buFont typeface="Noto Sans CJK JP"/>
@@ -11916,7 +11916,7 @@
                 <a:ea typeface="Noto Sans CJK JP"/>
                 <a:cs typeface="Noto Sans"/>
               </a:rPr>
-              <a:t>メニューやパネルの構造を手掛かりに候補領域を選び、画像を切り出して段階的に絞り込む。</a:t>
+              <a:t>Liら（2025）は、計画役にGPT-4o、位置推定役にOS-Atlas-7Bを使った。</a:t>
             </a:r>
           </a:p>
         </p:txBody>
@@ -13918,7 +13918,7 @@
                 <a:ea typeface="Noto Sans CJK JP"/>
                 <a:cs typeface="Noto Sans"/>
               </a:rPr>
-              <a:t>専門ソフトは、多くの道具と設定を高解像度の画面に並べる。画面全体に対して、個々の操作対象が小さくなる。</a:t>
+              <a:t>専門ソフトは、多くのツールや設定を高解像度の画面に配置するため、画面全体に対して個々の操作対象が小さくなる。</a:t>
             </a:r>
           </a:p>
           <a:p>
@@ -14578,7 +14578,7 @@
                 <a:ea typeface="Noto Sans CJK JP"/>
                 <a:cs typeface="Noto Sans"/>
               </a:rPr>
-              <a:t>正解の四角形は操作できる部分を囲む。文字の手掛かりの有無に基づきtextとiconを分類する。</a:t>
+              <a:t>正解の四角形は操作できる部分を囲む。文字の手掛かりの有無に基づきtextとiconに分類する。</a:t>
             </a:r>
           </a:p>
         </p:txBody>
@@ -19172,23 +19172,23 @@
                 <a:spcPct val="110000"/>
               </a:lnSpc>
               <a:buNone/>
-              <a:defRPr sz="2800" b="0">
-                <a:solidFill>
-                  <a:srgbClr val="303437"/>
-                </a:solidFill>
-                <a:latin typeface="Noto Sans"/>
-              </a:defRPr>
-            </a:pPr>
-            <a:r>
-              <a:rPr sz="2800" b="1" lang="ja-JP" altLang="en-US">
-                <a:solidFill>
-                  <a:srgbClr val="303437"/>
-                </a:solidFill>
-                <a:latin typeface="Noto Sans"/>
-                <a:ea typeface="Noto Sans CJK JP"/>
-                <a:cs typeface="Noto Sans"/>
-              </a:rPr>
-              <a:t>ScreenSpot-Proは専門画面の位置推定を測る</a:t>
+              <a:defRPr sz="2500" b="0">
+                <a:solidFill>
+                  <a:srgbClr val="303437"/>
+                </a:solidFill>
+                <a:latin typeface="Noto Sans"/>
+              </a:defRPr>
+            </a:pPr>
+            <a:r>
+              <a:rPr sz="2500" b="1" lang="ja-JP" altLang="en-US">
+                <a:solidFill>
+                  <a:srgbClr val="303437"/>
+                </a:solidFill>
+                <a:latin typeface="Noto Sans"/>
+                <a:ea typeface="Noto Sans CJK JP"/>
+                <a:cs typeface="Noto Sans"/>
+              </a:rPr>
+              <a:t>ScreenSpot-Proは専門画面の位置推定を評価する</a:t>
             </a:r>
           </a:p>
         </p:txBody>
@@ -30349,6 +30349,114 @@
                           <a:ea typeface="Noto Sans CJK JP"/>
                           <a:cs typeface="Noto Sans"/>
                         </a:rPr>
+                        <a:t>2560 × 1440</a:t>
+                      </a:r>
+                    </a:p>
+                  </a:txBody>
+                  <a:tcPr marL="63500" marR="63500" marT="38100" marB="38100" anchor="ctr">
+                    <a:lnL w="7620">
+                      <a:noFill/>
+                    </a:lnL>
+                    <a:lnR w="7620">
+                      <a:noFill/>
+                    </a:lnR>
+                    <a:lnT w="7620">
+                      <a:solidFill>
+                        <a:srgbClr val="626669"/>
+                      </a:solidFill>
+                      <a:prstDash val="solid"/>
+                    </a:lnT>
+                    <a:lnB w="7620">
+                      <a:noFill/>
+                    </a:lnB>
+                    <a:solidFill>
+                      <a:srgbClr val="FFFEF8"/>
+                    </a:solidFill>
+                  </a:tcPr>
+                </a:tc>
+                <a:tc>
+                  <a:txBody>
+                    <a:bodyPr wrap="square">
+                      <a:noAutofit/>
+                    </a:bodyPr>
+                    <a:lstStyle/>
+                    <a:p>
+                      <a:pPr algn="r">
+                        <a:lnSpc>
+                          <a:spcPts val="2070"/>
+                        </a:lnSpc>
+                        <a:buNone/>
+                        <a:defRPr sz="1800" b="0">
+                          <a:solidFill>
+                            <a:srgbClr val="303437"/>
+                          </a:solidFill>
+                          <a:latin typeface="Noto Sans"/>
+                        </a:defRPr>
+                      </a:pPr>
+                      <a:r>
+                        <a:rPr sz="1800" b="0" lang="ja-JP" altLang="en-US">
+                          <a:solidFill>
+                            <a:srgbClr val="303437"/>
+                          </a:solidFill>
+                          <a:latin typeface="Noto Sans"/>
+                          <a:ea typeface="Noto Sans CJK JP"/>
+                          <a:cs typeface="Noto Sans"/>
+                        </a:rPr>
+                        <a:t>514</a:t>
+                      </a:r>
+                    </a:p>
+                  </a:txBody>
+                  <a:tcPr marL="63500" marR="63500" marT="38100" marB="38100" anchor="ctr">
+                    <a:lnL w="7620">
+                      <a:noFill/>
+                    </a:lnL>
+                    <a:lnR w="7620">
+                      <a:noFill/>
+                    </a:lnR>
+                    <a:lnT w="7620">
+                      <a:solidFill>
+                        <a:srgbClr val="626669"/>
+                      </a:solidFill>
+                      <a:prstDash val="solid"/>
+                    </a:lnT>
+                    <a:lnB w="7620">
+                      <a:noFill/>
+                    </a:lnB>
+                    <a:solidFill>
+                      <a:srgbClr val="FFFEF8"/>
+                    </a:solidFill>
+                  </a:tcPr>
+                </a:tc>
+              </a:tr>
+              <a:tr h="374904">
+                <a:tc>
+                  <a:txBody>
+                    <a:bodyPr wrap="square">
+                      <a:noAutofit/>
+                    </a:bodyPr>
+                    <a:lstStyle/>
+                    <a:p>
+                      <a:pPr algn="l">
+                        <a:lnSpc>
+                          <a:spcPts val="2070"/>
+                        </a:lnSpc>
+                        <a:buNone/>
+                        <a:defRPr sz="1800" b="0">
+                          <a:solidFill>
+                            <a:srgbClr val="303437"/>
+                          </a:solidFill>
+                          <a:latin typeface="Noto Sans"/>
+                        </a:defRPr>
+                      </a:pPr>
+                      <a:r>
+                        <a:rPr sz="1800" b="0" lang="ja-JP" altLang="en-US">
+                          <a:solidFill>
+                            <a:srgbClr val="303437"/>
+                          </a:solidFill>
+                          <a:latin typeface="Noto Sans"/>
+                          <a:ea typeface="Noto Sans CJK JP"/>
+                          <a:cs typeface="Noto Sans"/>
+                        </a:rPr>
                         <a:t>3840 × 2160</a:t>
                       </a:r>
                     </a:p>
@@ -30361,10 +30469,7 @@
                       <a:noFill/>
                     </a:lnR>
                     <a:lnT w="7620">
-                      <a:solidFill>
-                        <a:srgbClr val="626669"/>
-                      </a:solidFill>
-                      <a:prstDash val="solid"/>
+                      <a:noFill/>
                     </a:lnT>
                     <a:lnB w="7620">
                       <a:noFill/>
@@ -30414,10 +30519,7 @@
                       <a:noFill/>
                     </a:lnR>
                     <a:lnT w="7620">
-                      <a:solidFill>
-                        <a:srgbClr val="626669"/>
-                      </a:solidFill>
-                      <a:prstDash val="solid"/>
+                      <a:noFill/>
                     </a:lnT>
                     <a:lnB w="7620">
                       <a:noFill/>
@@ -30508,108 +30610,6 @@
                           <a:cs typeface="Noto Sans"/>
                         </a:rPr>
                         <a:t>181</a:t>
-                      </a:r>
-                    </a:p>
-                  </a:txBody>
-                  <a:tcPr marL="63500" marR="63500" marT="38100" marB="38100" anchor="ctr">
-                    <a:lnL w="7620">
-                      <a:noFill/>
-                    </a:lnL>
-                    <a:lnR w="7620">
-                      <a:noFill/>
-                    </a:lnR>
-                    <a:lnT w="7620">
-                      <a:noFill/>
-                    </a:lnT>
-                    <a:lnB w="7620">
-                      <a:noFill/>
-                    </a:lnB>
-                    <a:solidFill>
-                      <a:srgbClr val="FFFEF8"/>
-                    </a:solidFill>
-                  </a:tcPr>
-                </a:tc>
-              </a:tr>
-              <a:tr h="374904">
-                <a:tc>
-                  <a:txBody>
-                    <a:bodyPr wrap="square">
-                      <a:noAutofit/>
-                    </a:bodyPr>
-                    <a:lstStyle/>
-                    <a:p>
-                      <a:pPr algn="l">
-                        <a:lnSpc>
-                          <a:spcPts val="2070"/>
-                        </a:lnSpc>
-                        <a:buNone/>
-                        <a:defRPr sz="1800" b="0">
-                          <a:solidFill>
-                            <a:srgbClr val="303437"/>
-                          </a:solidFill>
-                          <a:latin typeface="Noto Sans"/>
-                        </a:defRPr>
-                      </a:pPr>
-                      <a:r>
-                        <a:rPr sz="1800" b="0" lang="ja-JP" altLang="en-US">
-                          <a:solidFill>
-                            <a:srgbClr val="303437"/>
-                          </a:solidFill>
-                          <a:latin typeface="Noto Sans"/>
-                          <a:ea typeface="Noto Sans CJK JP"/>
-                          <a:cs typeface="Noto Sans"/>
-                        </a:rPr>
-                        <a:t>2560 × 1440</a:t>
-                      </a:r>
-                    </a:p>
-                  </a:txBody>
-                  <a:tcPr marL="63500" marR="63500" marT="38100" marB="38100" anchor="ctr">
-                    <a:lnL w="7620">
-                      <a:noFill/>
-                    </a:lnL>
-                    <a:lnR w="7620">
-                      <a:noFill/>
-                    </a:lnR>
-                    <a:lnT w="7620">
-                      <a:noFill/>
-                    </a:lnT>
-                    <a:lnB w="7620">
-                      <a:noFill/>
-                    </a:lnB>
-                    <a:solidFill>
-                      <a:srgbClr val="FFFEF8"/>
-                    </a:solidFill>
-                  </a:tcPr>
-                </a:tc>
-                <a:tc>
-                  <a:txBody>
-                    <a:bodyPr wrap="square">
-                      <a:noAutofit/>
-                    </a:bodyPr>
-                    <a:lstStyle/>
-                    <a:p>
-                      <a:pPr algn="r">
-                        <a:lnSpc>
-                          <a:spcPts val="2070"/>
-                        </a:lnSpc>
-                        <a:buNone/>
-                        <a:defRPr sz="1800" b="0">
-                          <a:solidFill>
-                            <a:srgbClr val="303437"/>
-                          </a:solidFill>
-                          <a:latin typeface="Noto Sans"/>
-                        </a:defRPr>
-                      </a:pPr>
-                      <a:r>
-                        <a:rPr sz="1800" b="0" lang="ja-JP" altLang="en-US">
-                          <a:solidFill>
-                            <a:srgbClr val="303437"/>
-                          </a:solidFill>
-                          <a:latin typeface="Noto Sans"/>
-                          <a:ea typeface="Noto Sans CJK JP"/>
-                          <a:cs typeface="Noto Sans"/>
-                        </a:rPr>
-                        <a:t>514</a:t>
                       </a:r>
                     </a:p>
                   </a:txBody>
@@ -32374,7 +32374,7 @@
                           <a:ea typeface="Noto Sans CJK JP"/>
                           <a:cs typeface="Noto Sans"/>
                         </a:rPr>
-                        <a:t>量</a:t>
+                        <a:t>項目</a:t>
                       </a:r>
                     </a:p>
                   </a:txBody>
@@ -33626,7 +33626,7 @@
                 <a:ea typeface="Noto Sans CJK JP"/>
                 <a:cs typeface="Noto Sans"/>
               </a:rPr>
-              <a:t>公式eval_sample_positive_gtの判定条件を、説明用に変数名を整理して抜粋。</a:t>
+              <a:t>公式のeval_sample_positive_gtにおける判定条件を、説明用に変数名を整理して抜粋。</a:t>
             </a:r>
           </a:p>
         </p:txBody>
@@ -33783,7 +33783,7 @@
                 <a:ea typeface="Noto Sans CJK JP"/>
                 <a:cs typeface="Noto Sans"/>
               </a:rPr>
-              <a:t>中国語の指示も同じ画面へ対応する</a:t>
+              <a:t>中国語の指示も同じ画面に対応する</a:t>
             </a:r>
           </a:p>
         </p:txBody>
@@ -33836,7 +33836,7 @@
                 <a:ea typeface="Noto Sans CJK JP"/>
                 <a:cs typeface="Noto Sans"/>
               </a:rPr>
-              <a:t>公開注釈にはinstructionとinstruction_cnがあり、同じ対象について英語・中国語の指示を持つ。</a:t>
+              <a:t>公開注釈にはinstructionとinstruction_cnがあり、同じ対象に対する英語・中国語の指示が含まれる。</a:t>
             </a:r>
           </a:p>
           <a:p>
@@ -33866,7 +33866,7 @@
                 <a:ea typeface="Noto Sans CJK JP"/>
                 <a:cs typeface="Noto Sans"/>
               </a:rPr>
-              <a:t>中国語はGPT-4による初期翻訳を、著者らが確認・修正して作成した。</a:t>
+              <a:t>中国語の指示は、GPT-4による初期翻訳を著者らが確認・修正したものである。</a:t>
             </a:r>
           </a:p>
           <a:p>
@@ -34976,7 +34976,7 @@
                 <a:ea typeface="Noto Sans CJK JP"/>
                 <a:cs typeface="Noto Sans"/>
               </a:rPr>
-              <a:t>専門家による画面の収集、正解領域の注釈、初期評価とScreenSeekeRを説明する。</a:t>
+              <a:t>専門家による画面の収集、正解領域の注釈、初期評価、およびScreenSeekeRについて説明する。</a:t>
             </a:r>
           </a:p>
           <a:p>
@@ -36826,7 +36826,7 @@
                 <a:ea typeface="Noto Sans CJK JP"/>
                 <a:cs typeface="Noto Sans"/>
               </a:rPr>
-              <a:t>実例1は、更新アイコンの位置を答える</a:t>
+              <a:t>実例1では、更新アイコンの位置を答える</a:t>
             </a:r>
           </a:p>
         </p:txBody>

</xml_diff>